<commit_message>
updated cases study 3
</commit_message>
<xml_diff>
--- a/2_drugSensitivity/Figure3_case2.pptx
+++ b/2_drugSensitivity/Figure3_case2.pptx
@@ -13513,36 +13513,6 @@
           </a:p>
         </p:txBody>
       </p:sp>
-      <p:pic>
-        <p:nvPicPr>
-          <p:cNvPr id="115" name="Picture 114">
-            <a:extLst>
-              <a:ext uri="{FF2B5EF4-FFF2-40B4-BE49-F238E27FC236}">
-                <a16:creationId xmlns:a16="http://schemas.microsoft.com/office/drawing/2014/main" id="{22E435DA-347F-6152-F796-B3F8B7D6220A}"/>
-              </a:ext>
-            </a:extLst>
-          </p:cNvPr>
-          <p:cNvPicPr>
-            <a:picLocks noChangeAspect="1"/>
-          </p:cNvPicPr>
-          <p:nvPr/>
-        </p:nvPicPr>
-        <p:blipFill>
-          <a:blip r:embed="rId13"/>
-          <a:stretch>
-            <a:fillRect/>
-          </a:stretch>
-        </p:blipFill>
-        <p:spPr>
-          <a:xfrm>
-            <a:off x="7221252" y="7454872"/>
-            <a:ext cx="11067523" cy="2528302"/>
-          </a:xfrm>
-          <a:prstGeom prst="rect">
-            <a:avLst/>
-          </a:prstGeom>
-        </p:spPr>
-      </p:pic>
       <p:sp>
         <p:nvSpPr>
           <p:cNvPr id="116" name="Google Shape;95;p1">
@@ -13595,6 +13565,36 @@
           </a:p>
         </p:txBody>
       </p:sp>
+      <p:pic>
+        <p:nvPicPr>
+          <p:cNvPr id="123" name="Picture 122">
+            <a:extLst>
+              <a:ext uri="{FF2B5EF4-FFF2-40B4-BE49-F238E27FC236}">
+                <a16:creationId xmlns:a16="http://schemas.microsoft.com/office/drawing/2014/main" id="{061302A0-3CB8-37B0-BDDB-C1C8A8A82CE3}"/>
+              </a:ext>
+            </a:extLst>
+          </p:cNvPr>
+          <p:cNvPicPr>
+            <a:picLocks noChangeAspect="1"/>
+          </p:cNvPicPr>
+          <p:nvPr/>
+        </p:nvPicPr>
+        <p:blipFill>
+          <a:blip r:embed="rId13"/>
+          <a:stretch>
+            <a:fillRect/>
+          </a:stretch>
+        </p:blipFill>
+        <p:spPr>
+          <a:xfrm>
+            <a:off x="7293777" y="7298689"/>
+            <a:ext cx="11134018" cy="2618302"/>
+          </a:xfrm>
+          <a:prstGeom prst="rect">
+            <a:avLst/>
+          </a:prstGeom>
+        </p:spPr>
+      </p:pic>
     </p:spTree>
   </p:cSld>
   <p:clrMapOvr>

</xml_diff>

<commit_message>
final repo, need to be cleaned
</commit_message>
<xml_diff>
--- a/2_drugSensitivity/Figure3_case2.pptx
+++ b/2_drugSensitivity/Figure3_case2.pptx
@@ -249,8 +249,11 @@
     </a:lvl9pPr>
   </p:defaultTextStyle>
   <p:extLst>
+    <p:ext uri="{EFAFB233-063F-42B5-8137-9DF3F51BA10A}">
+      <p15:sldGuideLst xmlns:p15="http://schemas.microsoft.com/office/powerpoint/2012/main"/>
+    </p:ext>
     <p:ext uri="GoogleSlidesCustomDataVersion2">
-      <go:slidesCustomData xmlns:go="http://customooxmlschemas.google.com/" xmlns:ahyp="http://schemas.microsoft.com/office/drawing/2018/hyperlinkcolor" xmlns:p15="http://schemas.microsoft.com/office/powerpoint/2012/main" xmlns:p14="http://schemas.microsoft.com/office/powerpoint/2010/main" xmlns:com="http://schemas.openxmlformats.org/drawingml/2006/compatibility" xmlns:pvml="urn:schemas-microsoft-com:office:powerpoint" xmlns:v="urn:schemas-microsoft-com:vml" xmlns:o="urn:schemas-microsoft-com:office:office" xmlns:dgm="http://schemas.openxmlformats.org/drawingml/2006/diagram" xmlns:c="http://schemas.openxmlformats.org/drawingml/2006/chart" xmlns:mv="urn:schemas-microsoft-com:mac:vml" xmlns:mc="http://schemas.openxmlformats.org/markup-compatibility/2006" xmlns="" r:id="rId8" roundtripDataSignature="AMtx7mhfnrVQrRcpZDcEMkrk0w6Yo+xwwQ=="/>
+      <go:slidesCustomData xmlns="" xmlns:mc="http://schemas.openxmlformats.org/markup-compatibility/2006" xmlns:mv="urn:schemas-microsoft-com:mac:vml" xmlns:c="http://schemas.openxmlformats.org/drawingml/2006/chart" xmlns:dgm="http://schemas.openxmlformats.org/drawingml/2006/diagram" xmlns:o="urn:schemas-microsoft-com:office:office" xmlns:v="urn:schemas-microsoft-com:vml" xmlns:pvml="urn:schemas-microsoft-com:office:powerpoint" xmlns:com="http://schemas.openxmlformats.org/drawingml/2006/compatibility" xmlns:p14="http://schemas.microsoft.com/office/powerpoint/2010/main" xmlns:p15="http://schemas.microsoft.com/office/powerpoint/2012/main" xmlns:ahyp="http://schemas.microsoft.com/office/drawing/2018/hyperlinkcolor" xmlns:go="http://customooxmlschemas.google.com/" r:id="rId8" roundtripDataSignature="AMtx7mhfnrVQrRcpZDcEMkrk0w6Yo+xwwQ=="/>
     </p:ext>
   </p:extLst>
 </p:presentation>
@@ -11761,6 +11764,66 @@
       </p:grpSpPr>
       <p:pic>
         <p:nvPicPr>
+          <p:cNvPr id="5" name="Picture 4">
+            <a:extLst>
+              <a:ext uri="{FF2B5EF4-FFF2-40B4-BE49-F238E27FC236}">
+                <a16:creationId xmlns:a16="http://schemas.microsoft.com/office/drawing/2014/main" id="{0E0D12F0-C2B3-5AD1-59E4-4E993DF78CF9}"/>
+              </a:ext>
+            </a:extLst>
+          </p:cNvPr>
+          <p:cNvPicPr>
+            <a:picLocks noChangeAspect="1"/>
+          </p:cNvPicPr>
+          <p:nvPr/>
+        </p:nvPicPr>
+        <p:blipFill>
+          <a:blip r:embed="rId3"/>
+          <a:stretch>
+            <a:fillRect/>
+          </a:stretch>
+        </p:blipFill>
+        <p:spPr>
+          <a:xfrm>
+            <a:off x="16012481" y="3537464"/>
+            <a:ext cx="5951769" cy="3686937"/>
+          </a:xfrm>
+          <a:prstGeom prst="rect">
+            <a:avLst/>
+          </a:prstGeom>
+        </p:spPr>
+      </p:pic>
+      <p:pic>
+        <p:nvPicPr>
+          <p:cNvPr id="3" name="Picture 2">
+            <a:extLst>
+              <a:ext uri="{FF2B5EF4-FFF2-40B4-BE49-F238E27FC236}">
+                <a16:creationId xmlns:a16="http://schemas.microsoft.com/office/drawing/2014/main" id="{9A98CE56-A6B8-2F6E-30E0-A0C9B6855D1D}"/>
+              </a:ext>
+            </a:extLst>
+          </p:cNvPr>
+          <p:cNvPicPr>
+            <a:picLocks noChangeAspect="1"/>
+          </p:cNvPicPr>
+          <p:nvPr/>
+        </p:nvPicPr>
+        <p:blipFill>
+          <a:blip r:embed="rId4"/>
+          <a:stretch>
+            <a:fillRect/>
+          </a:stretch>
+        </p:blipFill>
+        <p:spPr>
+          <a:xfrm>
+            <a:off x="18501494" y="163634"/>
+            <a:ext cx="4330700" cy="3124200"/>
+          </a:xfrm>
+          <a:prstGeom prst="rect">
+            <a:avLst/>
+          </a:prstGeom>
+        </p:spPr>
+      </p:pic>
+      <p:pic>
+        <p:nvPicPr>
           <p:cNvPr id="121" name="Picture 120">
             <a:extLst>
               <a:ext uri="{FF2B5EF4-FFF2-40B4-BE49-F238E27FC236}">
@@ -11774,7 +11837,7 @@
           <p:nvPr/>
         </p:nvPicPr>
         <p:blipFill>
-          <a:blip r:embed="rId3"/>
+          <a:blip r:embed="rId5"/>
           <a:stretch>
             <a:fillRect/>
           </a:stretch>
@@ -11804,7 +11867,7 @@
           <p:nvPr/>
         </p:nvPicPr>
         <p:blipFill>
-          <a:blip r:embed="rId4"/>
+          <a:blip r:embed="rId6"/>
           <a:stretch>
             <a:fillRect/>
           </a:stretch>
@@ -11813,66 +11876,6 @@
           <a:xfrm>
             <a:off x="108175" y="163634"/>
             <a:ext cx="6380902" cy="9405183"/>
-          </a:xfrm>
-          <a:prstGeom prst="rect">
-            <a:avLst/>
-          </a:prstGeom>
-        </p:spPr>
-      </p:pic>
-      <p:pic>
-        <p:nvPicPr>
-          <p:cNvPr id="83" name="Picture 82">
-            <a:extLst>
-              <a:ext uri="{FF2B5EF4-FFF2-40B4-BE49-F238E27FC236}">
-                <a16:creationId xmlns:a16="http://schemas.microsoft.com/office/drawing/2014/main" id="{09FF32C2-7D53-15BF-3F3B-6BA7E4FB9EAD}"/>
-              </a:ext>
-            </a:extLst>
-          </p:cNvPr>
-          <p:cNvPicPr>
-            <a:picLocks noChangeAspect="1"/>
-          </p:cNvPicPr>
-          <p:nvPr/>
-        </p:nvPicPr>
-        <p:blipFill>
-          <a:blip r:embed="rId5"/>
-          <a:stretch>
-            <a:fillRect/>
-          </a:stretch>
-        </p:blipFill>
-        <p:spPr>
-          <a:xfrm>
-            <a:off x="15926216" y="3644979"/>
-            <a:ext cx="5944347" cy="3682339"/>
-          </a:xfrm>
-          <a:prstGeom prst="rect">
-            <a:avLst/>
-          </a:prstGeom>
-        </p:spPr>
-      </p:pic>
-      <p:pic>
-        <p:nvPicPr>
-          <p:cNvPr id="85" name="Picture 84">
-            <a:extLst>
-              <a:ext uri="{FF2B5EF4-FFF2-40B4-BE49-F238E27FC236}">
-                <a16:creationId xmlns:a16="http://schemas.microsoft.com/office/drawing/2014/main" id="{A3DA2CF3-CE82-8BF3-B5D7-8ACB41A570E7}"/>
-              </a:ext>
-            </a:extLst>
-          </p:cNvPr>
-          <p:cNvPicPr>
-            <a:picLocks noChangeAspect="1"/>
-          </p:cNvPicPr>
-          <p:nvPr/>
-        </p:nvPicPr>
-        <p:blipFill>
-          <a:blip r:embed="rId6"/>
-          <a:stretch>
-            <a:fillRect/>
-          </a:stretch>
-        </p:blipFill>
-        <p:spPr>
-          <a:xfrm>
-            <a:off x="18482477" y="163634"/>
-            <a:ext cx="4469177" cy="3224098"/>
           </a:xfrm>
           <a:prstGeom prst="rect">
             <a:avLst/>
@@ -13379,36 +13382,6 @@
           </a:p>
         </p:txBody>
       </p:sp>
-      <p:pic>
-        <p:nvPicPr>
-          <p:cNvPr id="109" name="Picture 108">
-            <a:extLst>
-              <a:ext uri="{FF2B5EF4-FFF2-40B4-BE49-F238E27FC236}">
-                <a16:creationId xmlns:a16="http://schemas.microsoft.com/office/drawing/2014/main" id="{45865CFB-3C87-230F-72AD-96D148114BEC}"/>
-              </a:ext>
-            </a:extLst>
-          </p:cNvPr>
-          <p:cNvPicPr>
-            <a:picLocks noChangeAspect="1"/>
-          </p:cNvPicPr>
-          <p:nvPr/>
-        </p:nvPicPr>
-        <p:blipFill>
-          <a:blip r:embed="rId12"/>
-          <a:stretch>
-            <a:fillRect/>
-          </a:stretch>
-        </p:blipFill>
-        <p:spPr>
-          <a:xfrm>
-            <a:off x="7013295" y="3616391"/>
-            <a:ext cx="7843210" cy="3526282"/>
-          </a:xfrm>
-          <a:prstGeom prst="rect">
-            <a:avLst/>
-          </a:prstGeom>
-        </p:spPr>
-      </p:pic>
       <p:sp>
         <p:nvSpPr>
           <p:cNvPr id="110" name="Google Shape;95;p1">
@@ -13580,7 +13553,7 @@
           <p:nvPr/>
         </p:nvPicPr>
         <p:blipFill>
-          <a:blip r:embed="rId13"/>
+          <a:blip r:embed="rId12"/>
           <a:stretch>
             <a:fillRect/>
           </a:stretch>
@@ -13589,6 +13562,36 @@
           <a:xfrm>
             <a:off x="7293777" y="7298689"/>
             <a:ext cx="11134018" cy="2618302"/>
+          </a:xfrm>
+          <a:prstGeom prst="rect">
+            <a:avLst/>
+          </a:prstGeom>
+        </p:spPr>
+      </p:pic>
+      <p:pic>
+        <p:nvPicPr>
+          <p:cNvPr id="7" name="Picture 6">
+            <a:extLst>
+              <a:ext uri="{FF2B5EF4-FFF2-40B4-BE49-F238E27FC236}">
+                <a16:creationId xmlns:a16="http://schemas.microsoft.com/office/drawing/2014/main" id="{614F4FE2-CCCA-8282-18AF-A50038DE9A5B}"/>
+              </a:ext>
+            </a:extLst>
+          </p:cNvPr>
+          <p:cNvPicPr>
+            <a:picLocks noChangeAspect="1"/>
+          </p:cNvPicPr>
+          <p:nvPr/>
+        </p:nvPicPr>
+        <p:blipFill>
+          <a:blip r:embed="rId13"/>
+          <a:stretch>
+            <a:fillRect/>
+          </a:stretch>
+        </p:blipFill>
+        <p:spPr>
+          <a:xfrm>
+            <a:off x="7269275" y="3537464"/>
+            <a:ext cx="7728834" cy="3474859"/>
           </a:xfrm>
           <a:prstGeom prst="rect">
             <a:avLst/>

</xml_diff>